<commit_message>
Reinclui Lucas Nelson Atallah (5 integrantes)
Co-Authored-By: Claude Opus 5.5 <noreply@anthropic.com>
</commit_message>
<xml_diff>
--- a/lavra/Lavra-Apresentacao-AUTH.pptx
+++ b/lavra/Lavra-Apresentacao-AUTH.pptx
@@ -115,26 +115,26 @@
   <p:extLst>
     <p:ext uri="{521415D9-36F7-43E2-AB2F-B90AF26B5E84}">
       <p14:sectionLst xmlns:p14="http://schemas.microsoft.com/office/powerpoint/2010/main">
-        <p14:section name="Abertura" id="{d56ce36e-d6bf-0d4e-1556-b592d7e6dc61}">
+        <p14:section name="Abertura" id="{539a582d-c6e7-3454-ab4c-4994f7d807fa}">
           <p14:sldIdLst>
             <p14:sldId id="256"/>
             <p14:sldId id="257"/>
           </p14:sldIdLst>
         </p14:section>
-        <p14:section name="Marca e mercado" id="{ac0e13a0-a82d-ee6c-8fa0-710d74e5bb69}">
+        <p14:section name="Marca e mercado" id="{b1d4c326-004a-1853-38f5-985636cd242b}">
           <p14:sldIdLst>
             <p14:sldId id="258"/>
             <p14:sldId id="259"/>
           </p14:sldIdLst>
         </p14:section>
-        <p14:section name="Execução" id="{bc97c0d7-7293-6c33-31ce-c6b102d25869}">
+        <p14:section name="Execução" id="{83dbc078-a783-2dce-c5fe-6bb3976a6872}">
           <p14:sldIdLst>
             <p14:sldId id="260"/>
             <p14:sldId id="261"/>
             <p14:sldId id="262"/>
           </p14:sldIdLst>
         </p14:section>
-        <p14:section name="Crise e fechamento" id="{5a2fb480-ea78-6555-0c44-2481c075266e}">
+        <p14:section name="Crise e fechamento" id="{b234046b-8263-5cc0-3d15-e7cddd03c816}">
           <p14:sldIdLst>
             <p14:sldId id="263"/>
             <p14:sldId id="264"/>
@@ -1378,7 +1378,7 @@
       </p:grpSpPr>
       <p:pic>
         <p:nvPicPr>
-          <p:cNvPr id="2" name="Image 0" descr="C:\Users\seabr\AppData\Local\Temp\claude\E--FGV-Mat-ria-1---Argo\c4d7e261-d73f-472c-9140-61ea97bb4631\scratchpad\ppt\simbolo-cacau.png">    </p:cNvPr>
+          <p:cNvPr id="2" name="Image 0" descr="E:\FGV\Matéria 1 - Argo\Desafio 2\geradores\figuras\simbolo-cacau.png">    </p:cNvPr>
           <p:cNvPicPr>
             <a:picLocks noChangeAspect="1"/>
           </p:cNvPicPr>
@@ -1557,7 +1557,7 @@
       </p:grpSpPr>
       <p:pic>
         <p:nvPicPr>
-          <p:cNvPr id="2" name="Image 0" descr="C:\Users\seabr\AppData\Local\Temp\claude\E--FGV-Mat-ria-1---Argo\c4d7e261-d73f-472c-9140-61ea97bb4631\scratchpad\ppt\simbolo-polpa.png">    </p:cNvPr>
+          <p:cNvPr id="2" name="Image 0" descr="E:\FGV\Matéria 1 - Argo\Desafio 2\geradores\figuras\simbolo-polpa.png">    </p:cNvPr>
           <p:cNvPicPr>
             <a:picLocks noChangeAspect="1"/>
           </p:cNvPicPr>
@@ -2344,7 +2344,7 @@
         <p:spPr>
           <a:xfrm>
             <a:off x="6583680" y="1463040"/>
-            <a:ext cx="2377440" cy="2011680"/>
+            <a:ext cx="2377440" cy="2560320"/>
           </a:xfrm>
           <a:prstGeom prst="rect">
             <a:avLst/>
@@ -2432,6 +2432,26 @@
                 <a:cs typeface="Arial" pitchFamily="34" charset="-120"/>
               </a:rPr>
               <a:t>Jorge Alberto Portiglioti</a:t>
+            </a:r>
+            <a:endParaRPr lang="en-US" sz="1600" dirty="0"/>
+          </a:p>
+          <a:p>
+            <a:pPr indent="0" marL="0">
+              <a:spcAft>
+                <a:spcPts val="1000"/>
+              </a:spcAft>
+              <a:buNone/>
+            </a:pPr>
+            <a:r>
+              <a:rPr lang="en-US" sz="1600" dirty="0">
+                <a:solidFill>
+                  <a:schemeClr val="accent2"/>
+                </a:solidFill>
+                <a:latin typeface="Arial" pitchFamily="34" charset="0"/>
+                <a:ea typeface="Arial" pitchFamily="34" charset="-122"/>
+                <a:cs typeface="Arial" pitchFamily="34" charset="-120"/>
+              </a:rPr>
+              <a:t>Lucas Nelson Atallah</a:t>
             </a:r>
             <a:endParaRPr lang="en-US" sz="1600" dirty="0"/>
           </a:p>
@@ -7053,7 +7073,7 @@
                 <a:ea typeface="Courier New" pitchFamily="34" charset="-122"/>
                 <a:cs typeface="Courier New" pitchFamily="34" charset="-120"/>
               </a:rPr>
-              <a:t>Obrigado · Gabriel · Giovanna · Igor · Jorge · Equipe AUTH</a:t>
+              <a:t>Obrigado · Gabriel · Giovanna · Igor · Jorge · Lucas · Equipe AUTH</a:t>
             </a:r>
             <a:endParaRPr lang="en-US" sz="1400" dirty="0"/>
           </a:p>

</xml_diff>